<commit_message>
snolab: backup slide with the event bookkeeping, step by step
2207 selected -> 276 (12.5%) fit in no channel -> 104 more miss a core
channel -> 1827 (83%) enter the sum; PDS2/PFS2 are channel-level cuts.

Co-Authored-By: Claude Fable 5 <noreply@anthropic.com>
Claude-Session: https://claude.ai/code/session_019MZR3HgnQZywyouv79Zw89
</commit_message>
<xml_diff>
--- a/snolab_run4_phonon_pulse_analysis/collection_efficiency/presentation/SNOLAB_R4_collection_efficiency_20260910.pptx
+++ b/snolab_run4_phonon_pulse_analysis/collection_efficiency/presentation/SNOLAB_R4_collection_efficiency_20260910.pptx
@@ -23,6 +23,7 @@
     <p:sldId id="271" r:id="rId23"/>
     <p:sldId id="272" r:id="rId24"/>
     <p:sldId id="273" r:id="rId25"/>
+    <p:sldId id="274" r:id="rId26"/>
   </p:sldIdLst>
   <p:sldSz cx="12191695" cy="6858000" type="screen4x3"/>
   <p:notesSz cx="6858000" cy="9144000"/>
@@ -1146,6 +1147,76 @@
           <a:p>
             <a:r>
               <a:t>Every channel is right-skewed; the peaks must not be added (21% low), the means add. PDS2 left out.</a:t>
+            </a:r>
+          </a:p>
+        </p:txBody>
+      </p:sp>
+      <p:sp>
+        <p:nvSpPr>
+          <p:cNvPr id="4" name="Slide Number Placeholder 3"/>
+          <p:cNvSpPr>
+            <a:spLocks noGrp="1"/>
+          </p:cNvSpPr>
+          <p:nvPr>
+            <p:ph type="sldNum" idx="5" sz="quarter"/>
+          </p:nvPr>
+        </p:nvSpPr>
+        <p:spPr/>
+      </p:sp>
+    </p:spTree>
+  </p:cSld>
+  <p:clrMapOvr>
+    <a:masterClrMapping/>
+  </p:clrMapOvr>
+</p:notes>
+</file>
+
+<file path=ppt/notesSlides/notesSlide19.xml><?xml version="1.0" encoding="utf-8"?>
+<p:notes xmlns:a="http://schemas.openxmlformats.org/drawingml/2006/main" xmlns:p="http://schemas.openxmlformats.org/presentationml/2006/main" xmlns:r="http://schemas.openxmlformats.org/officeDocument/2006/relationships">
+  <p:cSld>
+    <p:spTree>
+      <p:nvGrpSpPr>
+        <p:cNvPr id="1" name=""/>
+        <p:cNvGrpSpPr/>
+        <p:nvPr/>
+      </p:nvGrpSpPr>
+      <p:grpSpPr>
+        <a:xfrm>
+          <a:off x="0" y="0"/>
+          <a:ext cx="0" cy="0"/>
+          <a:chOff x="0" y="0"/>
+          <a:chExt cx="0" cy="0"/>
+        </a:xfrm>
+      </p:grpSpPr>
+      <p:sp>
+        <p:nvSpPr>
+          <p:cNvPr id="2" name="Slide Image Placeholder 1"/>
+          <p:cNvSpPr>
+            <a:spLocks noGrp="1"/>
+          </p:cNvSpPr>
+          <p:nvPr>
+            <p:ph type="sldImg" idx="2"/>
+          </p:nvPr>
+        </p:nvSpPr>
+        <p:spPr/>
+      </p:sp>
+      <p:sp>
+        <p:nvSpPr>
+          <p:cNvPr id="3" name="Notes Placeholder 2"/>
+          <p:cNvSpPr>
+            <a:spLocks noGrp="1"/>
+          </p:cNvSpPr>
+          <p:nvPr>
+            <p:ph type="body" idx="3" sz="quarter"/>
+          </p:nvPr>
+        </p:nvSpPr>
+        <p:spPr/>
+        <p:txBody>
+          <a:bodyPr/>
+          <a:lstStyle/>
+          <a:p>
+            <a:r>
+              <a:t>2207 selected; 276 fit nowhere (12.5%); 104 more miss at least one of the 10 core channels; 1827 (83%) enter the sum. PDS2 excluded as a channel (fits 42%), PFS2 has no data.</a:t>
             </a:r>
           </a:p>
         </p:txBody>
@@ -6426,6 +6497,254 @@
           </a:prstGeom>
         </p:spPr>
       </p:pic>
+    </p:spTree>
+  </p:cSld>
+  <p:clrMapOvr>
+    <a:masterClrMapping/>
+  </p:clrMapOvr>
+</p:sld>
+</file>
+
+<file path=ppt/slides/slide19.xml><?xml version="1.0" encoding="utf-8"?>
+<p:sld xmlns:a="http://schemas.openxmlformats.org/drawingml/2006/main" xmlns:p="http://schemas.openxmlformats.org/presentationml/2006/main" xmlns:r="http://schemas.openxmlformats.org/officeDocument/2006/relationships">
+  <p:cSld>
+    <p:spTree>
+      <p:nvGrpSpPr>
+        <p:cNvPr id="1" name=""/>
+        <p:cNvGrpSpPr/>
+        <p:nvPr/>
+      </p:nvGrpSpPr>
+      <p:grpSpPr/>
+      <p:sp>
+        <p:nvSpPr>
+          <p:cNvPr id="2" name="TextBox 1"/>
+          <p:cNvSpPr txBox="1"/>
+          <p:nvPr/>
+        </p:nvSpPr>
+        <p:spPr>
+          <a:xfrm>
+            <a:off x="502920" y="228600"/>
+            <a:ext cx="11247120" cy="731520"/>
+          </a:xfrm>
+          <a:prstGeom prst="rect">
+            <a:avLst/>
+          </a:prstGeom>
+          <a:noFill/>
+        </p:spPr>
+        <p:txBody>
+          <a:bodyPr wrap="square">
+            <a:spAutoFit/>
+          </a:bodyPr>
+          <a:lstStyle/>
+          <a:p>
+            <a:r>
+              <a:rPr sz="2700" b="1" i="0">
+                <a:solidFill>
+                  <a:srgbClr val="1F3864"/>
+                </a:solidFill>
+                <a:latin typeface="Arial"/>
+              </a:rPr>
+              <a:t>Backup — event bookkeeping: what is excluded at each step</a:t>
+            </a:r>
+          </a:p>
+        </p:txBody>
+      </p:sp>
+      <p:sp>
+        <p:nvSpPr>
+          <p:cNvPr id="3" name="Rectangle 2"/>
+          <p:cNvSpPr/>
+          <p:nvPr/>
+        </p:nvSpPr>
+        <p:spPr>
+          <a:xfrm>
+            <a:off x="502920" y="969264"/>
+            <a:ext cx="11247120" cy="18000"/>
+          </a:xfrm>
+          <a:prstGeom prst="rect">
+            <a:avLst/>
+          </a:prstGeom>
+          <a:solidFill>
+            <a:srgbClr val="1F3864"/>
+          </a:solidFill>
+          <a:ln>
+            <a:noFill/>
+          </a:ln>
+        </p:spPr>
+        <p:style>
+          <a:lnRef idx="1">
+            <a:schemeClr val="accent1"/>
+          </a:lnRef>
+          <a:fillRef idx="3">
+            <a:schemeClr val="accent1"/>
+          </a:fillRef>
+          <a:effectRef idx="2">
+            <a:schemeClr val="accent1"/>
+          </a:effectRef>
+          <a:fontRef idx="minor">
+            <a:schemeClr val="lt1"/>
+          </a:fontRef>
+        </p:style>
+        <p:txBody>
+          <a:bodyPr rtlCol="0" anchor="ctr"/>
+          <a:lstStyle/>
+          <a:p>
+            <a:pPr algn="ctr"/>
+          </a:p>
+        </p:txBody>
+      </p:sp>
+      <p:sp>
+        <p:nvSpPr>
+          <p:cNvPr id="4" name="TextBox 3"/>
+          <p:cNvSpPr txBox="1"/>
+          <p:nvPr/>
+        </p:nvSpPr>
+        <p:spPr>
+          <a:xfrm>
+            <a:off x="11430000" y="6446520"/>
+            <a:ext cx="548640" cy="320040"/>
+          </a:xfrm>
+          <a:prstGeom prst="rect">
+            <a:avLst/>
+          </a:prstGeom>
+          <a:noFill/>
+        </p:spPr>
+        <p:txBody>
+          <a:bodyPr wrap="square">
+            <a:spAutoFit/>
+          </a:bodyPr>
+          <a:lstStyle/>
+          <a:p>
+            <a:r>
+              <a:rPr sz="1000" b="0" i="0">
+                <a:solidFill>
+                  <a:srgbClr val="666666"/>
+                </a:solidFill>
+                <a:latin typeface="Arial"/>
+              </a:rPr>
+              <a:t>19</a:t>
+            </a:r>
+          </a:p>
+        </p:txBody>
+      </p:sp>
+      <p:sp>
+        <p:nvSpPr>
+          <p:cNvPr id="5" name="TextBox 4"/>
+          <p:cNvSpPr txBox="1"/>
+          <p:nvPr/>
+        </p:nvSpPr>
+        <p:spPr>
+          <a:xfrm>
+            <a:off x="502920" y="1463040"/>
+            <a:ext cx="11247120" cy="4572000"/>
+          </a:xfrm>
+          <a:prstGeom prst="rect">
+            <a:avLst/>
+          </a:prstGeom>
+          <a:noFill/>
+        </p:spPr>
+        <p:txBody>
+          <a:bodyPr wrap="square">
+            <a:spAutoFit/>
+          </a:bodyPr>
+          <a:lstStyle/>
+          <a:p>
+            <a:pPr>
+              <a:spcAft>
+                <a:spcPts val="800"/>
+              </a:spcAft>
+            </a:pPr>
+            <a:r>
+              <a:rPr sz="1700" b="0" i="0">
+                <a:solidFill>
+                  <a:srgbClr val="333333"/>
+                </a:solidFill>
+                <a:latin typeface="Arial"/>
+              </a:rPr>
+              <a:t>PTOFamps window around the K line (30 series, no trigger cut):   2207 events</a:t>
+            </a:r>
+          </a:p>
+          <a:p>
+            <a:pPr>
+              <a:spcAft>
+                <a:spcPts val="800"/>
+              </a:spcAft>
+            </a:pPr>
+            <a:r>
+              <a:rPr sz="1700" b="0" i="0">
+                <a:solidFill>
+                  <a:srgbClr val="333333"/>
+                </a:solidFill>
+                <a:latin typeface="Arial"/>
+              </a:rPr>
+              <a:t>− 276 events (12.5 %): the two-exponential fit fails in every channel (all NRMSE &gt; 0.2) — pileup / glitches, not checked one by one</a:t>
+            </a:r>
+          </a:p>
+          <a:p>
+            <a:pPr>
+              <a:spcAft>
+                <a:spcPts val="800"/>
+              </a:spcAft>
+            </a:pPr>
+            <a:r>
+              <a:rPr sz="1700" b="0" i="0">
+                <a:solidFill>
+                  <a:srgbClr val="333333"/>
+                </a:solidFill>
+                <a:latin typeface="Arial"/>
+              </a:rPr>
+              <a:t>= 1931 events with at least one usable fit</a:t>
+            </a:r>
+          </a:p>
+          <a:p>
+            <a:pPr>
+              <a:spcAft>
+                <a:spcPts val="800"/>
+              </a:spcAft>
+            </a:pPr>
+            <a:r>
+              <a:rPr sz="1700" b="0" i="0">
+                <a:solidFill>
+                  <a:srgbClr val="333333"/>
+                </a:solidFill>
+                <a:latin typeface="Arial"/>
+              </a:rPr>
+              <a:t>− 104 events: at least one of the 10 core channels failed to fit — an incomplete sum would read low</a:t>
+            </a:r>
+          </a:p>
+          <a:p>
+            <a:pPr>
+              <a:spcAft>
+                <a:spcPts val="800"/>
+              </a:spcAft>
+            </a:pPr>
+            <a:r>
+              <a:rPr sz="1700" b="1" i="0">
+                <a:solidFill>
+                  <a:srgbClr val="C0392B"/>
+                </a:solidFill>
+                <a:latin typeface="Arial"/>
+              </a:rPr>
+              <a:t>= 1827 events (83 % of 2207) enter the summed-energy distribution</a:t>
+            </a:r>
+          </a:p>
+          <a:p>
+            <a:pPr>
+              <a:spcAft>
+                <a:spcPts val="800"/>
+              </a:spcAft>
+            </a:pPr>
+            <a:r>
+              <a:rPr sz="1700" b="0" i="0">
+                <a:solidFill>
+                  <a:srgbClr val="333333"/>
+                </a:solidFill>
+                <a:latin typeface="Arial"/>
+              </a:rPr>
+              <a:t>Channel-level cuts, applied separately:   PDS2 left out (fits only 42 % of events, the ones near it) · PFS2 has no data on Z7</a:t>
+            </a:r>
+          </a:p>
+        </p:txBody>
+      </p:sp>
     </p:spTree>
   </p:cSld>
   <p:clrMapOvr>

</xml_diff>

<commit_message>
snolab: I0 histogram per channel and series, backup slide; two bias states found
scripts/i0_histogram.py reads every series' detectorConfig and histograms
I0 per channel weighted by the 1827 events in the sum. The 30 series fall
into two bias states (June 17-20 vs June 21-23, |I0| +10 %, R0 -20 %);
the analysis applies the first series' bias point everywhere. Fitted
pulses agree between the states within 2 %; the official per-series Eabs
is 16.5 % lower in the second state. Documented in NOTES 13 as open.

Co-Authored-By: Claude Fable 5.1 <noreply@anthropic.com>
Claude-Session: https://claude.ai/code/session_019MZR3HgnQZywyouv79Zw89
</commit_message>
<xml_diff>
--- a/snolab_run4_phonon_pulse_analysis/collection_efficiency/presentation/SNOLAB_R4_collection_efficiency_20260910.pptx
+++ b/snolab_run4_phonon_pulse_analysis/collection_efficiency/presentation/SNOLAB_R4_collection_efficiency_20260910.pptx
@@ -24,6 +24,7 @@
     <p:sldId id="272" r:id="rId24"/>
     <p:sldId id="273" r:id="rId25"/>
     <p:sldId id="274" r:id="rId26"/>
+    <p:sldId id="275" r:id="rId27"/>
   </p:sldIdLst>
   <p:sldSz cx="12191695" cy="6858000" type="screen4x3"/>
   <p:notesSz cx="6858000" cy="9144000"/>
@@ -1287,6 +1288,76 @@
           <a:p>
             <a:r>
               <a:t>Efficiency = energy absorbed by the TESs, summed over all channels, / 10.37 keV, for a detector operated at 0 V (no NTL amplification). Z7, K-line events of the Ge activation, SNOLAB R4, 2207 events over 30 series.</a:t>
+            </a:r>
+          </a:p>
+        </p:txBody>
+      </p:sp>
+      <p:sp>
+        <p:nvSpPr>
+          <p:cNvPr id="4" name="Slide Number Placeholder 3"/>
+          <p:cNvSpPr>
+            <a:spLocks noGrp="1"/>
+          </p:cNvSpPr>
+          <p:nvPr>
+            <p:ph type="sldNum" idx="5" sz="quarter"/>
+          </p:nvPr>
+        </p:nvSpPr>
+        <p:spPr/>
+      </p:sp>
+    </p:spTree>
+  </p:cSld>
+  <p:clrMapOvr>
+    <a:masterClrMapping/>
+  </p:clrMapOvr>
+</p:notes>
+</file>
+
+<file path=ppt/notesSlides/notesSlide20.xml><?xml version="1.0" encoding="utf-8"?>
+<p:notes xmlns:a="http://schemas.openxmlformats.org/drawingml/2006/main" xmlns:p="http://schemas.openxmlformats.org/presentationml/2006/main" xmlns:r="http://schemas.openxmlformats.org/officeDocument/2006/relationships">
+  <p:cSld>
+    <p:spTree>
+      <p:nvGrpSpPr>
+        <p:cNvPr id="1" name=""/>
+        <p:cNvGrpSpPr/>
+        <p:nvPr/>
+      </p:nvGrpSpPr>
+      <p:grpSpPr>
+        <a:xfrm>
+          <a:off x="0" y="0"/>
+          <a:ext cx="0" cy="0"/>
+          <a:chOff x="0" y="0"/>
+          <a:chExt cx="0" cy="0"/>
+        </a:xfrm>
+      </p:grpSpPr>
+      <p:sp>
+        <p:nvSpPr>
+          <p:cNvPr id="2" name="Slide Image Placeholder 1"/>
+          <p:cNvSpPr>
+            <a:spLocks noGrp="1"/>
+          </p:cNvSpPr>
+          <p:nvPr>
+            <p:ph type="sldImg" idx="2"/>
+          </p:nvPr>
+        </p:nvSpPr>
+        <p:spPr/>
+      </p:sp>
+      <p:sp>
+        <p:nvSpPr>
+          <p:cNvPr id="3" name="Notes Placeholder 2"/>
+          <p:cNvSpPr>
+            <a:spLocks noGrp="1"/>
+          </p:cNvSpPr>
+          <p:nvPr>
+            <p:ph type="body" idx="3" sz="quarter"/>
+          </p:nvPr>
+        </p:nvSpPr>
+        <p:spPr/>
+        <p:txBody>
+          <a:bodyPr/>
+          <a:lstStyle/>
+          <a:p>
+            <a:r>
+              <a:t>One I0 per channel per series from detectorConfig, weighted by the 1827 events in the sum. Two bias states: 17 series (June 17-20) at the values used, 13 series (June 21-23) with |I0| 10% larger and R0 20% smaller. The analysis uses the first series' bias point everywhere; the fitted pulses (size and fall time) are the same in both states within 2%, the official per-series Eabs is 16.5% lower in the second state. Open item.</a:t>
             </a:r>
           </a:p>
         </p:txBody>
@@ -6965,6 +7036,214 @@
                 <a:latin typeface="Arial"/>
               </a:rPr>
               <a:t>Sample: Z7, the K-line events of the Ge activation run, from SNOLAB R4 (2207 events, 30 series, all 11 channels).</a:t>
+            </a:r>
+          </a:p>
+        </p:txBody>
+      </p:sp>
+    </p:spTree>
+  </p:cSld>
+  <p:clrMapOvr>
+    <a:masterClrMapping/>
+  </p:clrMapOvr>
+</p:sld>
+</file>
+
+<file path=ppt/slides/slide20.xml><?xml version="1.0" encoding="utf-8"?>
+<p:sld xmlns:a="http://schemas.openxmlformats.org/drawingml/2006/main" xmlns:p="http://schemas.openxmlformats.org/presentationml/2006/main" xmlns:r="http://schemas.openxmlformats.org/officeDocument/2006/relationships">
+  <p:cSld>
+    <p:spTree>
+      <p:nvGrpSpPr>
+        <p:cNvPr id="1" name=""/>
+        <p:cNvGrpSpPr/>
+        <p:nvPr/>
+      </p:nvGrpSpPr>
+      <p:grpSpPr/>
+      <p:sp>
+        <p:nvSpPr>
+          <p:cNvPr id="2" name="TextBox 1"/>
+          <p:cNvSpPr txBox="1"/>
+          <p:nvPr/>
+        </p:nvSpPr>
+        <p:spPr>
+          <a:xfrm>
+            <a:off x="502920" y="228600"/>
+            <a:ext cx="11247120" cy="731520"/>
+          </a:xfrm>
+          <a:prstGeom prst="rect">
+            <a:avLst/>
+          </a:prstGeom>
+          <a:noFill/>
+        </p:spPr>
+        <p:txBody>
+          <a:bodyPr wrap="square">
+            <a:spAutoFit/>
+          </a:bodyPr>
+          <a:lstStyle/>
+          <a:p>
+            <a:r>
+              <a:rPr sz="2700" b="1" i="0">
+                <a:solidFill>
+                  <a:srgbClr val="1F3864"/>
+                </a:solidFill>
+                <a:latin typeface="Arial"/>
+              </a:rPr>
+              <a:t>Backup — the TES bias current I₀ behind the coefficients</a:t>
+            </a:r>
+          </a:p>
+        </p:txBody>
+      </p:sp>
+      <p:sp>
+        <p:nvSpPr>
+          <p:cNvPr id="3" name="Rectangle 2"/>
+          <p:cNvSpPr/>
+          <p:nvPr/>
+        </p:nvSpPr>
+        <p:spPr>
+          <a:xfrm>
+            <a:off x="502920" y="969264"/>
+            <a:ext cx="11247120" cy="18000"/>
+          </a:xfrm>
+          <a:prstGeom prst="rect">
+            <a:avLst/>
+          </a:prstGeom>
+          <a:solidFill>
+            <a:srgbClr val="1F3864"/>
+          </a:solidFill>
+          <a:ln>
+            <a:noFill/>
+          </a:ln>
+        </p:spPr>
+        <p:style>
+          <a:lnRef idx="1">
+            <a:schemeClr val="accent1"/>
+          </a:lnRef>
+          <a:fillRef idx="3">
+            <a:schemeClr val="accent1"/>
+          </a:fillRef>
+          <a:effectRef idx="2">
+            <a:schemeClr val="accent1"/>
+          </a:effectRef>
+          <a:fontRef idx="minor">
+            <a:schemeClr val="lt1"/>
+          </a:fontRef>
+        </p:style>
+        <p:txBody>
+          <a:bodyPr rtlCol="0" anchor="ctr"/>
+          <a:lstStyle/>
+          <a:p>
+            <a:pPr algn="ctr"/>
+          </a:p>
+        </p:txBody>
+      </p:sp>
+      <p:sp>
+        <p:nvSpPr>
+          <p:cNvPr id="4" name="TextBox 3"/>
+          <p:cNvSpPr txBox="1"/>
+          <p:nvPr/>
+        </p:nvSpPr>
+        <p:spPr>
+          <a:xfrm>
+            <a:off x="11430000" y="6446520"/>
+            <a:ext cx="548640" cy="320040"/>
+          </a:xfrm>
+          <a:prstGeom prst="rect">
+            <a:avLst/>
+          </a:prstGeom>
+          <a:noFill/>
+        </p:spPr>
+        <p:txBody>
+          <a:bodyPr wrap="square">
+            <a:spAutoFit/>
+          </a:bodyPr>
+          <a:lstStyle/>
+          <a:p>
+            <a:r>
+              <a:rPr sz="1000" b="0" i="0">
+                <a:solidFill>
+                  <a:srgbClr val="666666"/>
+                </a:solidFill>
+                <a:latin typeface="Arial"/>
+              </a:rPr>
+              <a:t>20</a:t>
+            </a:r>
+          </a:p>
+        </p:txBody>
+      </p:sp>
+      <p:pic>
+        <p:nvPicPr>
+          <p:cNvPr id="5" name="Picture 4" descr="i0_histogram.png"/>
+          <p:cNvPicPr>
+            <a:picLocks noChangeAspect="1"/>
+          </p:cNvPicPr>
+          <p:nvPr/>
+        </p:nvPicPr>
+        <p:blipFill>
+          <a:blip r:embed="rId3"/>
+          <a:stretch>
+            <a:fillRect/>
+          </a:stretch>
+        </p:blipFill>
+        <p:spPr>
+          <a:xfrm>
+            <a:off x="2002715" y="1143000"/>
+            <a:ext cx="8247529" cy="4572000"/>
+          </a:xfrm>
+          <a:prstGeom prst="rect">
+            <a:avLst/>
+          </a:prstGeom>
+        </p:spPr>
+      </p:pic>
+      <p:sp>
+        <p:nvSpPr>
+          <p:cNvPr id="6" name="TextBox 5"/>
+          <p:cNvSpPr txBox="1"/>
+          <p:nvPr/>
+        </p:nvSpPr>
+        <p:spPr>
+          <a:xfrm>
+            <a:off x="502920" y="5715000"/>
+            <a:ext cx="11247120" cy="1005840"/>
+          </a:xfrm>
+          <a:prstGeom prst="rect">
+            <a:avLst/>
+          </a:prstGeom>
+          <a:noFill/>
+        </p:spPr>
+        <p:txBody>
+          <a:bodyPr wrap="square">
+            <a:spAutoFit/>
+          </a:bodyPr>
+          <a:lstStyle/>
+          <a:p>
+            <a:pPr>
+              <a:spcAft>
+                <a:spcPts val="800"/>
+              </a:spcAft>
+            </a:pPr>
+            <a:r>
+              <a:rPr sz="1200" b="0" i="0">
+                <a:solidFill>
+                  <a:srgbClr val="333333"/>
+                </a:solidFill>
+                <a:latin typeface="Arial"/>
+              </a:rPr>
+              <a:t>One I₀ per channel per series (detectorConfig, 30 series), weighted by the 1827 events in the sum. Red dashed: the value used for every series (first series, e.g. PBS1 −18.07 µA).</a:t>
+            </a:r>
+          </a:p>
+          <a:p>
+            <a:pPr>
+              <a:spcAft>
+                <a:spcPts val="800"/>
+              </a:spcAft>
+            </a:pPr>
+            <a:r>
+              <a:rPr sz="1200" b="1" i="0">
+                <a:solidFill>
+                  <a:srgbClr val="C0392B"/>
+                </a:solidFill>
+                <a:latin typeface="Arial"/>
+              </a:rPr>
+              <a:t>Two bias states: June 17–20 (1225 events) at the values used; June 21–23 (602 events) with |I₀| 10 % larger and R₀ 20 % smaller. The fitted pulses are the same in both (energy and fall time within 2 %); the official per-series Eabs is 16.5 % lower in the second state. Open item.</a:t>
             </a:r>
           </a:p>
         </p:txBody>

</xml_diff>

<commit_message>
snolab: backup slide names the standard Default_tag processing instead of 'official'
Co-Authored-By: Claude Fable 5.1 <noreply@anthropic.com>
Claude-Session: https://claude.ai/code/session_019MZR3HgnQZywyouv79Zw89
</commit_message>
<xml_diff>
--- a/snolab_run4_phonon_pulse_analysis/collection_efficiency/presentation/SNOLAB_R4_collection_efficiency_20260910.pptx
+++ b/snolab_run4_phonon_pulse_analysis/collection_efficiency/presentation/SNOLAB_R4_collection_efficiency_20260910.pptx
@@ -1357,7 +1357,7 @@
           <a:lstStyle/>
           <a:p>
             <a:r>
-              <a:t>One I0 per channel per series from detectorConfig, weighted by the 1827 events in the sum. Two bias states: 17 series (June 17-20) at the values used, 13 series (June 21-23) with |I0| 10% larger and R0 20% smaller. The analysis uses the first series' bias point everywhere; the fitted pulses (size and fall time) are the same in both states within 2%, the official per-series Eabs is 16.5% lower in the second state. Open item.</a:t>
+              <a:t>One I0 per channel per series from detectorConfig, weighted by the 1827 events in the sum. Two bias states: 17 series (June 17-20) at the values used, 13 series (June 21-23) with |I0| 10% larger and R0 20% smaller. The analysis uses the first series' bias point everywhere; the fitted pulses (size and fall time) are the same in both states within 2%, the standard Default_tag processing (per-series config) gives 16.5% less Eabs in the second state. Open item.</a:t>
             </a:r>
           </a:p>
         </p:txBody>
@@ -7243,7 +7243,7 @@
                 </a:solidFill>
                 <a:latin typeface="Arial"/>
               </a:rPr>
-              <a:t>Two bias states: June 17–20 (1225 events) at the values used; June 21–23 (602 events) with |I₀| 10 % larger and R₀ 20 % smaller. The fitted pulses are the same in both (energy and fall time within 2 %); the official per-series Eabs is 16.5 % lower in the second state. Open item.</a:t>
+              <a:t>Two bias states: June 17–20 (1225 events) at the values used; June 21–23 (602 events) with |I₀| 10 % larger and R₀ 20 % smaller. The fitted pulses are the same in both (energy and fall time within 2 %); the group's standard cdmsbats processing (Default_tag, per-series detectorConfig) gives 16.5 % less Eabs in the second state. Open item.</a:t>
             </a:r>
           </a:p>
         </p:txBody>

</xml_diff>

<commit_message>
snolab: result restricted to the 17 series before the June 21 re-bias (Prof. Liu): 30.4 %, sigma/mu 7.6 %
kline_energy_hist.py gains --before (default 24260621). 1442 events selected,
1225 in the sum, peak 3154.8 eV. The 30-series outputs are kept in
results/plots/bias_point_check/ as zip7_30series_*. Decks, script, READMEs
and NOTES 14 updated; the conclusion is unchanged.

Co-Authored-By: Claude Fable 5.1 <noreply@anthropic.com>
Claude-Session: https://claude.ai/code/session_019MZR3HgnQZywyouv79Zw89
</commit_message>
<xml_diff>
--- a/snolab_run4_phonon_pulse_analysis/collection_efficiency/presentation/SNOLAB_R4_collection_efficiency_20260910.pptx
+++ b/snolab_run4_phonon_pulse_analysis/collection_efficiency/presentation/SNOLAB_R4_collection_efficiency_20260910.pptx
@@ -591,7 +591,7 @@
           <a:lstStyle/>
           <a:p>
             <a:r>
-              <a:t>Grey: ten channels that fit ≥ 95% of events, 1827 events, 3162 eV = 30.5%, width 7.5% — the position dependence cancels in the sum. Uncertainty = sigma/mu of the Gaussian fit, 7.5% (Prof. Liu). PDS2 fits only 42%, and those are events near it, so it is left out. Red line 10.37 keV.</a:t>
+              <a:t>Grey: ten channels that fit ≥ 95% of events, 1225 events, 3155 eV = 30.4%, width 7.6% — the position dependence cancels in the sum. Uncertainty = sigma/mu of the Gaussian fit, 7.6% (Prof. Liu). PDS2 fits only 42%, and those are events near it, so it is left out. Red line 10.37 keV.</a:t>
             </a:r>
           </a:p>
         </p:txBody>
@@ -661,7 +661,7 @@
           <a:lstStyle/>
           <a:p>
             <a:r>
-              <a:t>Chain: current -&gt; power -&gt; energy -&gt; sum over 10 channels -&gt; 30.5% (sigma/mu 7.5%). R37 CUTE note: 26-41%. Open: Z7 only; HV bias unknown (0 V assumed); no dIdV, inductor term dropped; PDS2; 12.5% of events fit nowhere.</a:t>
+              <a:t>Chain: current -&gt; power -&gt; energy -&gt; sum over 10 channels, 17 series -&gt; 30.4% (sigma/mu 7.6%). R37 CUTE note: 26-41%. Open: Z7 only; HV bias unknown (0 V assumed); no dIdV, inductor term dropped; PDS2; 11% of events fit nowhere.</a:t>
             </a:r>
           </a:p>
         </p:txBody>
@@ -1217,7 +1217,7 @@
           <a:lstStyle/>
           <a:p>
             <a:r>
-              <a:t>2207 selected; 276 fit nowhere (12.5%); 104 more miss at least one of the 10 core channels; 1827 (83%) enter the sum. PDS2 excluded as a channel (fits 42%), PFS2 has no data.</a:t>
+              <a:t>17 series (June 17-20; the 13 later series sit at a different bias point and are left out, Prof. Liu). 1442 selected; 158 fit nowhere (11%); 59 more miss at least one of the 10 core channels; 1225 (85%) enter the sum. PDS2 excluded as a channel (fits 42%), PFS2 has no data.</a:t>
             </a:r>
           </a:p>
         </p:txBody>
@@ -1287,7 +1287,7 @@
           <a:lstStyle/>
           <a:p>
             <a:r>
-              <a:t>Efficiency = energy absorbed by the TESs, summed over all channels, / 10.37 keV, for a detector operated at 0 V (no NTL amplification). Z7, K-line events of the Ge activation, SNOLAB R4, 2207 events over 30 series.</a:t>
+              <a:t>Efficiency = energy absorbed by the TESs, summed over all channels, / 10.37 keV, for a detector operated at 0 V (no NTL amplification). Z7, K-line events of the Ge activation, SNOLAB R4, 1442 events over 17 series (the 13 series after the June 21 re-bias left out).</a:t>
             </a:r>
           </a:p>
         </p:txBody>
@@ -1357,7 +1357,7 @@
           <a:lstStyle/>
           <a:p>
             <a:r>
-              <a:t>One I0 per channel per series from detectorConfig, weighted by the 1827 events in the sum. Two bias states: 17 series (June 17-20) at the values used, 13 series (June 21-23) with |I0| 10% larger and R0 20% smaller. The analysis uses the first series' bias point everywhere; the fitted pulses (size and fall time) are the same in both states within 2%, the standard Default_tag processing (per-series config) gives 16.5% less Eabs in the second state. Open item.</a:t>
+              <a:t>One I0 per channel per series from detectorConfig, weighted by the events in the sum over all 30 series. Two bias states: 17 series (June 17-20) at the values used, 13 series (June 21-23) with |I0| 10% larger and R0 20% smaller. The analysis uses the first series' bias point everywhere; the fitted pulses (size and fall time) are the same in both states within 2%, the standard Default_tag processing (per-series config) gives 16.5% less Eabs in the second state. Open item.</a:t>
             </a:r>
           </a:p>
         </p:txBody>
@@ -1847,7 +1847,7 @@
           <a:lstStyle/>
           <a:p>
             <a:r>
-              <a:t>Red: fit. Grey outline: official window on the raw trace; same peak to 0.2%. Peak 285 eV, width 42 eV = 15%, for a fixed-energy line. Right tail to 600 eV: events near PBS1. The width is position, not noise.</a:t>
+              <a:t>Red: fit. Grey outline: official window on the raw trace; same peak to 0.2%. Peak 287 eV, width 42 eV = 15%, for a fixed-energy line. Right tail to 600 eV: events near PBS1. The width is position, not noise.</a:t>
             </a:r>
           </a:p>
         </p:txBody>
@@ -5013,7 +5013,7 @@
                 </a:solidFill>
                 <a:latin typeface="Arial"/>
               </a:rPr>
-              <a:t>Summed over the channels: 30.5 %</a:t>
+              <a:t>Summed over the channels: 30.4 %</a:t>
             </a:r>
           </a:p>
           <a:p>
@@ -5122,8 +5122,8 @@
         </p:blipFill>
         <p:spPr>
           <a:xfrm>
-            <a:off x="502920" y="1173806"/>
-            <a:ext cx="8046719" cy="5333348"/>
+            <a:off x="502920" y="1175434"/>
+            <a:ext cx="8046719" cy="5330092"/>
           </a:xfrm>
           <a:prstGeom prst="rect">
             <a:avLst/>
@@ -5164,7 +5164,7 @@
                 </a:solidFill>
                 <a:latin typeface="Arial"/>
               </a:rPr>
-              <a:t>Ten channels summed, 1827 events: 3162 eV = 30.5 %, and the width drops to 7.5 % — the position effect cancels.</a:t>
+              <a:t>Ten channels summed, 1225 events: 3155 eV = 30.4 %, and the width drops to 7.6 % — the position effect cancels.</a:t>
             </a:r>
           </a:p>
           <a:p>
@@ -5197,7 +5197,7 @@
                 <a:latin typeface="Arial"/>
               </a:rPr>
               <a:t>Collection efficiency:
-30.5 % ± 2.3 %  (σ/μ = 7.5 %).</a:t>
+30.4 % ± 2.3 %  (σ/μ = 7.6 %).</a:t>
             </a:r>
           </a:p>
           <a:p>
@@ -5413,7 +5413,7 @@
                 </a:solidFill>
                 <a:latin typeface="Arial"/>
               </a:rPr>
-              <a:t>Z7 absorbs 30.5 % ± 2.3 % (σ/μ = 7.5 %) of a 10.37 keV event in its TESs, summed over 10 channels.   The CDMS note reports 26–41 % on the R37 CUTE tower.</a:t>
+              <a:t>Z7 absorbs 30.4 % ± 2.3 % (σ/μ = 7.6 %) of a 10.37 keV event in its TESs, summed over 10 channels.   The CDMS note reports 26–41 % on the R37 CUTE tower.</a:t>
             </a:r>
           </a:p>
           <a:p>
@@ -5429,7 +5429,7 @@
                 </a:solidFill>
                 <a:latin typeface="Arial"/>
               </a:rPr>
-              <a:t>Open: Z7 only · the bias of Z7 is not established (0 V assumed) · no dI/dV · PDS2 not included · 12.5 % of events fit in no channel.</a:t>
+              <a:t>Open: Z7 only · the bias of Z7 is not established (0 V assumed) · no dI/dV · PDS2 not included · 11 % of events fit in no channel · 13 later series (different bias point) not used.</a:t>
             </a:r>
           </a:p>
         </p:txBody>
@@ -5766,7 +5766,7 @@
                 </a:solidFill>
                 <a:latin typeface="Arial"/>
               </a:rPr>
-              <a:t>The two differ only in the quadratic term: 1.7 % in energy (PBS1, median of 15 events) — far below the 15 % single-channel width and the 7.5 % width of the sum.</a:t>
+              <a:t>The two differ only in the quadratic term: 1.7 % in energy (PBS1, median of 15 events) — far below the 15 % single-channel width and the 7.6 % width of the sum.</a:t>
             </a:r>
           </a:p>
           <a:p>
@@ -6731,7 +6731,7 @@
                 </a:solidFill>
                 <a:latin typeface="Arial"/>
               </a:rPr>
-              <a:t>PTOFamps window around the K line (30 series, no trigger cut):   2207 events</a:t>
+              <a:t>17 series, June 17–20 (the 13 series from June 21 on sit at a different bias point and are left out)</a:t>
             </a:r>
           </a:p>
           <a:p>
@@ -6747,7 +6747,7 @@
                 </a:solidFill>
                 <a:latin typeface="Arial"/>
               </a:rPr>
-              <a:t>− 276 events (12.5 %): the two-exponential fit fails in every channel (all NRMSE &gt; 0.2) — pileup / glitches, not checked one by one</a:t>
+              <a:t>PTOFamps window around the K line (no trigger cut):   1442 events</a:t>
             </a:r>
           </a:p>
           <a:p>
@@ -6763,7 +6763,7 @@
                 </a:solidFill>
                 <a:latin typeface="Arial"/>
               </a:rPr>
-              <a:t>= 1931 events with at least one usable fit</a:t>
+              <a:t>− 158 events (11 %): the two-exponential fit fails in every channel (all NRMSE &gt; 0.2) — pileup / glitches, not checked one by one</a:t>
             </a:r>
           </a:p>
           <a:p>
@@ -6779,7 +6779,7 @@
                 </a:solidFill>
                 <a:latin typeface="Arial"/>
               </a:rPr>
-              <a:t>− 104 events: at least one of the 10 core channels failed to fit — an incomplete sum would read low</a:t>
+              <a:t>= 1284 events with at least one usable fit</a:t>
             </a:r>
           </a:p>
           <a:p>
@@ -6789,13 +6789,29 @@
               </a:spcAft>
             </a:pPr>
             <a:r>
-              <a:rPr sz="1700" b="1" i="0">
-                <a:solidFill>
-                  <a:srgbClr val="C0392B"/>
+              <a:rPr sz="1700" b="0" i="0">
+                <a:solidFill>
+                  <a:srgbClr val="333333"/>
                 </a:solidFill>
                 <a:latin typeface="Arial"/>
               </a:rPr>
-              <a:t>= 1827 events (83 % of 2207) enter the summed-energy distribution</a:t>
+              <a:t>− 59 events: at least one of the 10 core channels failed to fit — an incomplete sum would read low</a:t>
+            </a:r>
+          </a:p>
+          <a:p>
+            <a:pPr>
+              <a:spcAft>
+                <a:spcPts val="800"/>
+              </a:spcAft>
+            </a:pPr>
+            <a:r>
+              <a:rPr sz="1700" b="1" i="0">
+                <a:solidFill>
+                  <a:srgbClr val="C0392B"/>
+                </a:solidFill>
+                <a:latin typeface="Arial"/>
+              </a:rPr>
+              <a:t>= 1225 events (85 % of 1442) enter the summed-energy distribution</a:t>
             </a:r>
           </a:p>
           <a:p>
@@ -7035,7 +7051,7 @@
                 </a:solidFill>
                 <a:latin typeface="Arial"/>
               </a:rPr>
-              <a:t>Sample: Z7, the K-line events of the Ge activation run, from SNOLAB R4 (2207 events, 30 series, all 11 channels).</a:t>
+              <a:t>Sample: Z7, the K-line events of the Ge activation run, from SNOLAB R4 (1442 events, 17 series, all 11 channels).</a:t>
             </a:r>
           </a:p>
         </p:txBody>
@@ -7227,7 +7243,7 @@
                 </a:solidFill>
                 <a:latin typeface="Arial"/>
               </a:rPr>
-              <a:t>One I₀ per channel per series (detectorConfig, 30 series), weighted by the 1827 events in the sum. Red dashed: the value used for every series (first series, e.g. PBS1 −18.07 µA).</a:t>
+              <a:t>One I₀ per channel per series (detectorConfig, all 30 series), weighted by the events in the sum. Red dashed: the value used for every series (first series, e.g. PBS1 −18.07 µA).</a:t>
             </a:r>
           </a:p>
           <a:p>
@@ -7243,7 +7259,7 @@
                 </a:solidFill>
                 <a:latin typeface="Arial"/>
               </a:rPr>
-              <a:t>Two bias states: June 17–20 (1225 events) at the values used; June 21–23 (602 events) with |I₀| 10 % larger and R₀ 20 % smaller. The fitted pulses are the same in both (energy and fall time within 2 %); the group's standard cdmsbats processing (Default_tag, per-series detectorConfig) gives 16.5 % less Eabs in the second state. Open item.</a:t>
+              <a:t>Two bias states: June 17–20 (1225 events) at the values used; June 21–23 (602 events) with |I₀| 10 % larger and R₀ 20 % smaller. The fitted pulses are the same in both (energy and fall time within 2 %); the group's standard cdmsbats processing (Default_tag, per-series detectorConfig) gives 16.5 % less Eabs in the second state. Decision (Prof. Liu): the 13 later series are left out; the result uses the 17 series of the first state.</a:t>
             </a:r>
           </a:p>
         </p:txBody>
@@ -8568,7 +8584,7 @@
                 </a:solidFill>
                 <a:latin typeface="Arial"/>
               </a:rPr>
-              <a:t>PBS1, 1917 K-line events, one fit and one integral each</a:t>
+              <a:t>PBS1, 1273 K-line events, one fit and one integral each</a:t>
             </a:r>
           </a:p>
         </p:txBody>
@@ -8724,7 +8740,7 @@
                 </a:solidFill>
                 <a:latin typeface="Arial"/>
               </a:rPr>
-              <a:t>Peak 285 eV, width 15 % — for a line whose energy is fixed.</a:t>
+              <a:t>Peak 287 eV, width 15 % — for a line whose energy is fixed.</a:t>
             </a:r>
           </a:p>
           <a:p>

</xml_diff>

<commit_message>
snolab: backup slide 20 quotes the pulse comparison precisely (energy 1 %, time constants 4 %)
Co-Authored-By: Claude Fable 5.1 <noreply@anthropic.com>
Claude-Session: https://claude.ai/code/session_019MZR3HgnQZywyouv79Zw89
</commit_message>
<xml_diff>
--- a/snolab_run4_phonon_pulse_analysis/collection_efficiency/presentation/SNOLAB_R4_collection_efficiency_20260910.pptx
+++ b/snolab_run4_phonon_pulse_analysis/collection_efficiency/presentation/SNOLAB_R4_collection_efficiency_20260910.pptx
@@ -1357,7 +1357,7 @@
           <a:lstStyle/>
           <a:p>
             <a:r>
-              <a:t>One I0 per channel per series from detectorConfig, weighted by the events in the sum over all 30 series. Two bias states: 17 series (June 17-20) at the values used, 13 series (June 21-23) with |I0| 10% larger and R0 20% smaller. The analysis uses the first series' bias point everywhere; the fitted pulses (size and fall time) are the same in both states within 2%, the standard Default_tag processing (per-series config) gives 16.5% less Eabs in the second state. Open item.</a:t>
+              <a:t>One I0 per channel per series from detectorConfig, weighted by the events in the sum over all 30 series. Two bias states: 17 series (June 17-20) at the values used, 13 series (June 21-23) with |I0| 10% larger and R0 20% smaller. The analysis uses the first series' bias point everywhere; the fitted pulses are the same in both states (energy within 1%, time constants within 4%), the standard Default_tag processing (per-series config) gives 16.5% less Eabs in the second state. Open item.</a:t>
             </a:r>
           </a:p>
         </p:txBody>
@@ -7259,7 +7259,7 @@
                 </a:solidFill>
                 <a:latin typeface="Arial"/>
               </a:rPr>
-              <a:t>Two bias states: June 17–20 (1225 events) at the values used; June 21–23 (602 events) with |I₀| 10 % larger and R₀ 20 % smaller. The fitted pulses are the same in both (energy and fall time within 2 %); the group's standard cdmsbats processing (Default_tag, per-series detectorConfig) gives 16.5 % less Eabs in the second state. Decision (Prof. Liu): the 13 later series are left out; the result uses the 17 series of the first state.</a:t>
+              <a:t>Two bias states: June 17–20 (1225 events) at the values used; June 21–23 (602 events) with |I₀| 10 % larger and R₀ 20 % smaller. The fitted pulses are the same in both (energy within 1 %, rise and fall times within 4 %); the group's standard cdmsbats processing (Default_tag, per-series detectorConfig) gives 16.5 % less Eabs in the second state. Decision (Prof. Liu): the 13 later series are left out; the result uses the 17 series of the first state.</a:t>
             </a:r>
           </a:p>
         </p:txBody>

</xml_diff>